<commit_message>
remove lock file and update presentation
</commit_message>
<xml_diff>
--- a/docs/Pilares_POO_TodoList.pptx
+++ b/docs/Pilares_POO_TodoList.pptx
@@ -406,7 +406,7 @@
             <a:pPr indent="0" algn="r">
               <a:buNone/>
             </a:pPr>
-            <a:fld id="{AD38BFDA-3D63-40BE-A4FF-62F4626616D6}" type="slidenum">
+            <a:fld id="{262E936D-66D0-48C6-B0F0-86A1560A5E94}" type="slidenum">
               <a:rPr b="0" lang="pt-BR" sz="1400" strike="noStrike" u="none">
                 <a:solidFill>
                   <a:srgbClr val="000000"/>
@@ -590,7 +590,7 @@
                 <a:tab algn="l" pos="0"/>
               </a:tabLst>
             </a:pPr>
-            <a:fld id="{3C2A8797-FC68-4909-A22E-116959F97DE6}" type="slidenum">
+            <a:fld id="{8803792B-180B-4AA7-9D8D-02ECCB86C4D4}" type="slidenum">
               <a:rPr b="0" lang="en-US" sz="1200" strike="noStrike" u="none">
                 <a:solidFill>
                   <a:schemeClr val="dk1"/>
@@ -774,7 +774,7 @@
                 <a:tab algn="l" pos="0"/>
               </a:tabLst>
             </a:pPr>
-            <a:fld id="{DE736908-C0AC-41B8-B2AD-FB76BF23287A}" type="slidenum">
+            <a:fld id="{929A5D83-A070-4B35-B6B3-64AE734FD4D5}" type="slidenum">
               <a:rPr b="0" lang="en-US" sz="1200" strike="noStrike" u="none">
                 <a:solidFill>
                   <a:schemeClr val="dk1"/>
@@ -958,7 +958,7 @@
                 <a:tab algn="l" pos="0"/>
               </a:tabLst>
             </a:pPr>
-            <a:fld id="{C1EEBEEB-E886-418C-A2CF-7D2A158F31F0}" type="slidenum">
+            <a:fld id="{074D1595-878D-42FE-8676-737CBD3D1489}" type="slidenum">
               <a:rPr b="0" lang="en-US" sz="1200" strike="noStrike" u="none">
                 <a:solidFill>
                   <a:schemeClr val="dk1"/>
@@ -1142,7 +1142,7 @@
                 <a:tab algn="l" pos="0"/>
               </a:tabLst>
             </a:pPr>
-            <a:fld id="{252FAD60-A2E2-40EF-8EF2-BF332D57F308}" type="slidenum">
+            <a:fld id="{AA163723-0EE7-4F1A-8B6C-7EDA002733CE}" type="slidenum">
               <a:rPr b="0" lang="en-US" sz="1200" strike="noStrike" u="none">
                 <a:solidFill>
                   <a:schemeClr val="dk1"/>
@@ -1326,7 +1326,7 @@
                 <a:tab algn="l" pos="0"/>
               </a:tabLst>
             </a:pPr>
-            <a:fld id="{3071A0A3-76CA-4E92-B88B-F67F2CE73440}" type="slidenum">
+            <a:fld id="{9BC4FD04-37FF-41B5-A5EB-A50E82824546}" type="slidenum">
               <a:rPr b="0" lang="en-US" sz="1200" strike="noStrike" u="none">
                 <a:solidFill>
                   <a:schemeClr val="dk1"/>
@@ -1510,7 +1510,7 @@
                 <a:tab algn="l" pos="0"/>
               </a:tabLst>
             </a:pPr>
-            <a:fld id="{97709234-214D-4CB4-9A92-4365117B1F8E}" type="slidenum">
+            <a:fld id="{1E4F4715-5DFD-4D16-9649-A2255C8F4AF2}" type="slidenum">
               <a:rPr b="0" lang="en-US" sz="1200" strike="noStrike" u="none">
                 <a:solidFill>
                   <a:schemeClr val="dk1"/>
@@ -1694,7 +1694,7 @@
                 <a:tab algn="l" pos="0"/>
               </a:tabLst>
             </a:pPr>
-            <a:fld id="{85808D81-4406-440A-9452-6A9A478FAB91}" type="slidenum">
+            <a:fld id="{31E313A5-7760-4A2A-AA75-48405D49C992}" type="slidenum">
               <a:rPr b="0" lang="en-US" sz="1200" strike="noStrike" u="none">
                 <a:solidFill>
                   <a:schemeClr val="dk1"/>
@@ -1878,7 +1878,7 @@
                 <a:tab algn="l" pos="0"/>
               </a:tabLst>
             </a:pPr>
-            <a:fld id="{DF0BD28D-BFDD-4B7A-AABC-BCAE3E883FC5}" type="slidenum">
+            <a:fld id="{79626841-9347-422E-8373-E00268879A8E}" type="slidenum">
               <a:rPr b="0" lang="en-US" sz="1200" strike="noStrike" u="none">
                 <a:solidFill>
                   <a:schemeClr val="dk1"/>
@@ -2062,7 +2062,7 @@
                 <a:tab algn="l" pos="0"/>
               </a:tabLst>
             </a:pPr>
-            <a:fld id="{32997B67-6FBD-473A-B7AD-B7E4DE8A584B}" type="slidenum">
+            <a:fld id="{8E1FD4F7-AFFF-4464-A0F3-867F587C6F04}" type="slidenum">
               <a:rPr b="0" lang="en-US" sz="1200" strike="noStrike" u="none">
                 <a:solidFill>
                   <a:schemeClr val="dk1"/>
@@ -2812,7 +2812,7 @@
                 <a:tab algn="l" pos="0"/>
               </a:tabLst>
             </a:pPr>
-            <a:fld id="{B7678DBD-EEB4-4046-8934-6A76F2DFA6CB}" type="slidenum">
+            <a:fld id="{DBA8D7EE-EF7E-4174-BFFB-84DDDC79A780}" type="slidenum">
               <a:rPr b="0" lang="en-US" sz="1000" strike="noStrike" u="none">
                 <a:solidFill>
                   <a:schemeClr val="accent6"/>
@@ -2821,7 +2821,7 @@
                 <a:uFillTx/>
                 <a:latin typeface="Calibri"/>
               </a:rPr>
-              <a:t>&lt;número&gt;</a:t>
+              <a:t>9</a:t>
             </a:fld>
             <a:endParaRPr b="0" lang="pt-BR" sz="1000" strike="noStrike" u="none">
               <a:solidFill>
@@ -2885,7 +2885,18 @@
                 <a:uFillTx/>
                 <a:latin typeface="Calibri"/>
               </a:rPr>
-              <a:t>Clique para editar o formato de texto dos tópicos</a:t>
+              <a:t>Clique para editar o formato de texto dos </a:t>
+            </a:r>
+            <a:r>
+              <a:rPr b="0" lang="pt-BR" sz="3200" strike="noStrike" u="none">
+                <a:solidFill>
+                  <a:schemeClr val="dk1"/>
+                </a:solidFill>
+                <a:effectLst/>
+                <a:uFillTx/>
+                <a:latin typeface="Calibri"/>
+              </a:rPr>
+              <a:t>tópicos</a:t>
             </a:r>
             <a:endParaRPr b="0" lang="pt-BR" sz="3200" strike="noStrike" u="none">
               <a:solidFill>
@@ -5164,7 +5175,7 @@
                 <a:tab algn="l" pos="0"/>
               </a:tabLst>
             </a:pPr>
-            <a:fld id="{078B282A-DCF8-4EB6-ACD7-E06204BBDD64}" type="slidenum">
+            <a:fld id="{AA7A837B-CF79-44E9-BA38-2073A62188E8}" type="slidenum">
               <a:rPr b="0" lang="en-US" sz="1000" strike="noStrike" u="none">
                 <a:solidFill>
                   <a:schemeClr val="accent6"/>
@@ -5262,7 +5273,95 @@
                 <a:uFillTx/>
                 <a:latin typeface="Arial"/>
               </a:rPr>
-              <a:t>Rotas da API usadas pelo front-end</a:t>
+              <a:t>Rota</a:t>
+            </a:r>
+            <a:r>
+              <a:rPr b="1" lang="en-US" sz="3200" strike="noStrike" u="none">
+                <a:solidFill>
+                  <a:schemeClr val="dk2"/>
+                </a:solidFill>
+                <a:effectLst/>
+                <a:uFillTx/>
+                <a:latin typeface="Arial"/>
+              </a:rPr>
+              <a:t>s da </a:t>
+            </a:r>
+            <a:r>
+              <a:rPr b="1" lang="en-US" sz="3200" strike="noStrike" u="none">
+                <a:solidFill>
+                  <a:schemeClr val="dk2"/>
+                </a:solidFill>
+                <a:effectLst/>
+                <a:uFillTx/>
+                <a:latin typeface="Arial"/>
+              </a:rPr>
+              <a:t>API </a:t>
+            </a:r>
+            <a:r>
+              <a:rPr b="1" lang="en-US" sz="3200" strike="noStrike" u="none">
+                <a:solidFill>
+                  <a:schemeClr val="dk2"/>
+                </a:solidFill>
+                <a:effectLst/>
+                <a:uFillTx/>
+                <a:latin typeface="Arial"/>
+              </a:rPr>
+              <a:t>usa</a:t>
+            </a:r>
+            <a:r>
+              <a:rPr b="1" lang="en-US" sz="3200" strike="noStrike" u="none">
+                <a:solidFill>
+                  <a:schemeClr val="dk2"/>
+                </a:solidFill>
+                <a:effectLst/>
+                <a:uFillTx/>
+                <a:latin typeface="Arial"/>
+              </a:rPr>
+              <a:t>das </a:t>
+            </a:r>
+            <a:r>
+              <a:rPr b="1" lang="en-US" sz="3200" strike="noStrike" u="none">
+                <a:solidFill>
+                  <a:schemeClr val="dk2"/>
+                </a:solidFill>
+                <a:effectLst/>
+                <a:uFillTx/>
+                <a:latin typeface="Arial"/>
+              </a:rPr>
+              <a:t>pelo </a:t>
+            </a:r>
+            <a:r>
+              <a:rPr b="1" lang="en-US" sz="3200" strike="noStrike" u="none">
+                <a:solidFill>
+                  <a:schemeClr val="dk2"/>
+                </a:solidFill>
+                <a:effectLst/>
+                <a:uFillTx/>
+                <a:latin typeface="Arial"/>
+              </a:rPr>
+              <a:t>fron</a:t>
+            </a:r>
+            <a:r>
+              <a:rPr b="1" lang="en-US" sz="3200" strike="noStrike" u="none">
+                <a:solidFill>
+                  <a:schemeClr val="dk2"/>
+                </a:solidFill>
+                <a:effectLst/>
+                <a:uFillTx/>
+                <a:latin typeface="Arial"/>
+              </a:rPr>
+              <a:t>t-</a:t>
+            </a:r>
+            <a:r>
+              <a:rPr b="1" lang="en-US" sz="3200" strike="noStrike" u="none">
+                <a:solidFill>
+                  <a:schemeClr val="dk2"/>
+                </a:solidFill>
+                <a:effectLst/>
+                <a:uFillTx/>
+                <a:latin typeface="Arial"/>
+              </a:rPr>
+              <a:t>end</a:t>
             </a:r>
             <a:endParaRPr b="0" lang="pt-BR" sz="3200" strike="noStrike" u="none">
               <a:solidFill>
@@ -6733,7 +6832,7 @@
                 <a:tab algn="l" pos="0"/>
               </a:tabLst>
             </a:pPr>
-            <a:fld id="{A353ABAC-644F-4D31-B934-39291E4729AA}" type="slidenum">
+            <a:fld id="{9E572E06-E6F6-428D-A263-2D576C77197E}" type="slidenum">
               <a:rPr b="0" lang="en-US" sz="1000" strike="noStrike" u="none">
                 <a:solidFill>
                   <a:schemeClr val="accent6"/>
@@ -8512,7 +8611,7 @@
                 <a:tab algn="l" pos="0"/>
               </a:tabLst>
             </a:pPr>
-            <a:fld id="{4C813E43-2CDC-447F-AD8F-46BA6B176F26}" type="slidenum">
+            <a:fld id="{3B3A6EE1-1F54-4C12-91F0-6F406150073E}" type="slidenum">
               <a:rPr b="0" lang="en-US" sz="1000" strike="noStrike" u="none">
                 <a:solidFill>
                   <a:schemeClr val="accent6"/>
@@ -9887,7 +9986,7 @@
                 <a:tab algn="l" pos="0"/>
               </a:tabLst>
             </a:pPr>
-            <a:fld id="{E3C8B74B-E359-41F9-8C39-9541AC84EB6C}" type="slidenum">
+            <a:fld id="{2DDABDCD-7D2A-4AB3-AF0E-18217E4A42A7}" type="slidenum">
               <a:rPr b="0" lang="en-US" sz="1000" strike="noStrike" u="none">
                 <a:solidFill>
                   <a:schemeClr val="accent6"/>
@@ -9985,7 +10084,139 @@
                 <a:uFillTx/>
                 <a:latin typeface="Arial"/>
               </a:rPr>
-              <a:t>Encapsulamento: o objeto protege seus dados</a:t>
+              <a:t>Enc</a:t>
+            </a:r>
+            <a:r>
+              <a:rPr b="1" lang="en-US" sz="3200" strike="noStrike" u="none">
+                <a:solidFill>
+                  <a:schemeClr val="dk2"/>
+                </a:solidFill>
+                <a:effectLst/>
+                <a:uFillTx/>
+                <a:latin typeface="Arial"/>
+              </a:rPr>
+              <a:t>aps</a:t>
+            </a:r>
+            <a:r>
+              <a:rPr b="1" lang="en-US" sz="3200" strike="noStrike" u="none">
+                <a:solidFill>
+                  <a:schemeClr val="dk2"/>
+                </a:solidFill>
+                <a:effectLst/>
+                <a:uFillTx/>
+                <a:latin typeface="Arial"/>
+              </a:rPr>
+              <a:t>ula</a:t>
+            </a:r>
+            <a:r>
+              <a:rPr b="1" lang="en-US" sz="3200" strike="noStrike" u="none">
+                <a:solidFill>
+                  <a:schemeClr val="dk2"/>
+                </a:solidFill>
+                <a:effectLst/>
+                <a:uFillTx/>
+                <a:latin typeface="Arial"/>
+              </a:rPr>
+              <a:t>men</a:t>
+            </a:r>
+            <a:r>
+              <a:rPr b="1" lang="en-US" sz="3200" strike="noStrike" u="none">
+                <a:solidFill>
+                  <a:schemeClr val="dk2"/>
+                </a:solidFill>
+                <a:effectLst/>
+                <a:uFillTx/>
+                <a:latin typeface="Arial"/>
+              </a:rPr>
+              <a:t>to: o </a:t>
+            </a:r>
+            <a:r>
+              <a:rPr b="1" lang="en-US" sz="3200" strike="noStrike" u="none">
+                <a:solidFill>
+                  <a:schemeClr val="dk2"/>
+                </a:solidFill>
+                <a:effectLst/>
+                <a:uFillTx/>
+                <a:latin typeface="Arial"/>
+              </a:rPr>
+              <a:t>obje</a:t>
+            </a:r>
+            <a:r>
+              <a:rPr b="1" lang="en-US" sz="3200" strike="noStrike" u="none">
+                <a:solidFill>
+                  <a:schemeClr val="dk2"/>
+                </a:solidFill>
+                <a:effectLst/>
+                <a:uFillTx/>
+                <a:latin typeface="Arial"/>
+              </a:rPr>
+              <a:t>to </a:t>
+            </a:r>
+            <a:r>
+              <a:rPr b="1" lang="en-US" sz="3200" strike="noStrike" u="none">
+                <a:solidFill>
+                  <a:schemeClr val="dk2"/>
+                </a:solidFill>
+                <a:effectLst/>
+                <a:uFillTx/>
+                <a:latin typeface="Arial"/>
+              </a:rPr>
+              <a:t>prot</a:t>
+            </a:r>
+            <a:r>
+              <a:rPr b="1" lang="en-US" sz="3200" strike="noStrike" u="none">
+                <a:solidFill>
+                  <a:schemeClr val="dk2"/>
+                </a:solidFill>
+                <a:effectLst/>
+                <a:uFillTx/>
+                <a:latin typeface="Arial"/>
+              </a:rPr>
+              <a:t>ege </a:t>
+            </a:r>
+            <a:r>
+              <a:rPr b="1" lang="en-US" sz="3200" strike="noStrike" u="none">
+                <a:solidFill>
+                  <a:schemeClr val="dk2"/>
+                </a:solidFill>
+                <a:effectLst/>
+                <a:uFillTx/>
+                <a:latin typeface="Arial"/>
+              </a:rPr>
+              <a:t>seu</a:t>
+            </a:r>
+            <a:r>
+              <a:rPr b="1" lang="en-US" sz="3200" strike="noStrike" u="none">
+                <a:solidFill>
+                  <a:schemeClr val="dk2"/>
+                </a:solidFill>
+                <a:effectLst/>
+                <a:uFillTx/>
+                <a:latin typeface="Arial"/>
+              </a:rPr>
+              <a:t>s </a:t>
+            </a:r>
+            <a:r>
+              <a:rPr b="1" lang="en-US" sz="3200" strike="noStrike" u="none">
+                <a:solidFill>
+                  <a:schemeClr val="dk2"/>
+                </a:solidFill>
+                <a:effectLst/>
+                <a:uFillTx/>
+                <a:latin typeface="Arial"/>
+              </a:rPr>
+              <a:t>dad</a:t>
+            </a:r>
+            <a:r>
+              <a:rPr b="1" lang="en-US" sz="3200" strike="noStrike" u="none">
+                <a:solidFill>
+                  <a:schemeClr val="dk2"/>
+                </a:solidFill>
+                <a:effectLst/>
+                <a:uFillTx/>
+                <a:latin typeface="Arial"/>
+              </a:rPr>
+              <a:t>os</a:t>
             </a:r>
             <a:endParaRPr b="0" lang="pt-BR" sz="3200" strike="noStrike" u="none">
               <a:solidFill>
@@ -11847,7 +12078,7 @@
                 <a:tab algn="l" pos="0"/>
               </a:tabLst>
             </a:pPr>
-            <a:fld id="{34B5E5B4-9920-48AA-ACC0-80C0F1491AE6}" type="slidenum">
+            <a:fld id="{F29B533D-E33A-4F9F-8238-8385D6DC7816}" type="slidenum">
               <a:rPr b="0" lang="en-US" sz="1000" strike="noStrike" u="none">
                 <a:solidFill>
                   <a:schemeClr val="accent6"/>
@@ -13927,7 +14158,7 @@
                 <a:tab algn="l" pos="0"/>
               </a:tabLst>
             </a:pPr>
-            <a:fld id="{03D31F5E-1F56-4BE0-ACAD-05A629451181}" type="slidenum">
+            <a:fld id="{448B7D0E-AF4B-4834-8DDC-9CF5CD3C02A6}" type="slidenum">
               <a:rPr b="0" lang="en-US" sz="1000" strike="noStrike" u="none">
                 <a:solidFill>
                   <a:schemeClr val="accent6"/>
@@ -16067,7 +16298,7 @@
                 <a:tab algn="l" pos="0"/>
               </a:tabLst>
             </a:pPr>
-            <a:fld id="{D091D7BC-CB17-43CE-BCF0-DB493C46C30F}" type="slidenum">
+            <a:fld id="{BE95C2B3-ABD7-4488-A285-17BE608807B8}" type="slidenum">
               <a:rPr b="0" lang="en-US" sz="1000" strike="noStrike" u="none">
                 <a:solidFill>
                   <a:schemeClr val="accent6"/>
@@ -17813,7 +18044,7 @@
                 <a:tab algn="l" pos="0"/>
               </a:tabLst>
             </a:pPr>
-            <a:fld id="{6114E991-0B22-43F0-ACAA-228584BDFE60}" type="slidenum">
+            <a:fld id="{8798D813-E78E-474E-BD00-D166ABA427B5}" type="slidenum">
               <a:rPr b="0" lang="en-US" sz="1000" strike="noStrike" u="none">
                 <a:solidFill>
                   <a:schemeClr val="accent6"/>

</xml_diff>